<commit_message>
move all eval docs to a subdir, make eval scenarios' naming more clear
Signed-off-by: Amitfre15 <amitfrework@gmail.com>
</commit_message>
<xml_diff>
--- a/aiac/docs/presentations/aiac-eval-guardium.pptx
+++ b/aiac/docs/presentations/aiac-eval-guardium.pptx
@@ -1457,7 +1457,7 @@
           <a:p>
             <a:fld id="{F9A3712E-2F57-4671-928D-A021A37D8158}" type="datetimeFigureOut">
               <a:rPr lang="en-US" smtClean="0"/>
-              <a:t>8/20/2026</a:t>
+              <a:t>8/25/2026</a:t>
             </a:fld>
             <a:endParaRPr lang="en-US"/>
           </a:p>
@@ -2647,7 +2647,7 @@
           <a:p>
             <a:fld id="{5BCAD085-E8A6-8845-BD4E-CB4CCA059FC4}" type="datetimeFigureOut">
               <a:rPr lang="en-US" smtClean="0"/>
-              <a:t>8/20/2026</a:t>
+              <a:t>8/25/2026</a:t>
             </a:fld>
             <a:endParaRPr lang="en-US"/>
           </a:p>
@@ -2815,7 +2815,7 @@
           <a:p>
             <a:fld id="{5BCAD085-E8A6-8845-BD4E-CB4CCA059FC4}" type="datetimeFigureOut">
               <a:rPr lang="en-US" smtClean="0"/>
-              <a:t>8/20/2026</a:t>
+              <a:t>8/25/2026</a:t>
             </a:fld>
             <a:endParaRPr lang="en-US"/>
           </a:p>
@@ -2993,7 +2993,7 @@
           <a:p>
             <a:fld id="{5BCAD085-E8A6-8845-BD4E-CB4CCA059FC4}" type="datetimeFigureOut">
               <a:rPr lang="en-US" smtClean="0"/>
-              <a:t>8/20/2026</a:t>
+              <a:t>8/25/2026</a:t>
             </a:fld>
             <a:endParaRPr lang="en-US"/>
           </a:p>
@@ -3161,7 +3161,7 @@
           <a:p>
             <a:fld id="{5BCAD085-E8A6-8845-BD4E-CB4CCA059FC4}" type="datetimeFigureOut">
               <a:rPr lang="en-US" smtClean="0"/>
-              <a:t>8/20/2026</a:t>
+              <a:t>8/25/2026</a:t>
             </a:fld>
             <a:endParaRPr lang="en-US"/>
           </a:p>
@@ -3406,7 +3406,7 @@
           <a:p>
             <a:fld id="{5BCAD085-E8A6-8845-BD4E-CB4CCA059FC4}" type="datetimeFigureOut">
               <a:rPr lang="en-US" smtClean="0"/>
-              <a:t>8/20/2026</a:t>
+              <a:t>8/25/2026</a:t>
             </a:fld>
             <a:endParaRPr lang="en-US"/>
           </a:p>
@@ -3691,7 +3691,7 @@
           <a:p>
             <a:fld id="{5BCAD085-E8A6-8845-BD4E-CB4CCA059FC4}" type="datetimeFigureOut">
               <a:rPr lang="en-US" smtClean="0"/>
-              <a:t>8/20/2026</a:t>
+              <a:t>8/25/2026</a:t>
             </a:fld>
             <a:endParaRPr lang="en-US"/>
           </a:p>
@@ -4110,7 +4110,7 @@
           <a:p>
             <a:fld id="{5BCAD085-E8A6-8845-BD4E-CB4CCA059FC4}" type="datetimeFigureOut">
               <a:rPr lang="en-US" smtClean="0"/>
-              <a:t>8/20/2026</a:t>
+              <a:t>8/25/2026</a:t>
             </a:fld>
             <a:endParaRPr lang="en-US"/>
           </a:p>
@@ -4227,7 +4227,7 @@
           <a:p>
             <a:fld id="{5BCAD085-E8A6-8845-BD4E-CB4CCA059FC4}" type="datetimeFigureOut">
               <a:rPr lang="en-US" smtClean="0"/>
-              <a:t>8/20/2026</a:t>
+              <a:t>8/25/2026</a:t>
             </a:fld>
             <a:endParaRPr lang="en-US"/>
           </a:p>
@@ -4322,7 +4322,7 @@
           <a:p>
             <a:fld id="{5BCAD085-E8A6-8845-BD4E-CB4CCA059FC4}" type="datetimeFigureOut">
               <a:rPr lang="en-US" smtClean="0"/>
-              <a:t>8/20/2026</a:t>
+              <a:t>8/25/2026</a:t>
             </a:fld>
             <a:endParaRPr lang="en-US"/>
           </a:p>
@@ -4597,7 +4597,7 @@
           <a:p>
             <a:fld id="{5BCAD085-E8A6-8845-BD4E-CB4CCA059FC4}" type="datetimeFigureOut">
               <a:rPr lang="en-US" smtClean="0"/>
-              <a:t>8/20/2026</a:t>
+              <a:t>8/25/2026</a:t>
             </a:fld>
             <a:endParaRPr lang="en-US"/>
           </a:p>
@@ -4849,7 +4849,7 @@
           <a:p>
             <a:fld id="{5BCAD085-E8A6-8845-BD4E-CB4CCA059FC4}" type="datetimeFigureOut">
               <a:rPr lang="en-US" smtClean="0"/>
-              <a:t>8/20/2026</a:t>
+              <a:t>8/25/2026</a:t>
             </a:fld>
             <a:endParaRPr lang="en-US"/>
           </a:p>
@@ -5060,7 +5060,7 @@
           <a:p>
             <a:fld id="{5BCAD085-E8A6-8845-BD4E-CB4CCA059FC4}" type="datetimeFigureOut">
               <a:rPr lang="en-US" smtClean="0"/>
-              <a:t>8/20/2026</a:t>
+              <a:t>8/25/2026</a:t>
             </a:fld>
             <a:endParaRPr lang="en-US"/>
           </a:p>
@@ -14314,7 +14314,7 @@
         <p:spPr>
           <a:xfrm>
             <a:off x="932688" y="3188970"/>
-            <a:ext cx="4430268" cy="367280"/>
+            <a:ext cx="6375312" cy="367280"/>
           </a:xfrm>
           <a:prstGeom prst="rect">
             <a:avLst/>
@@ -14348,11 +14348,20 @@
                 </a:solidFill>
                 <a:latin typeface="Calibri"/>
               </a:rPr>
-              <a:t> (vs reference) / Best (no reference) rate</a:t>
-            </a:r>
-            <a:endParaRPr sz="1800" dirty="0">
+              <a:t> (vs reference) / Best (no reference) rate </a:t>
+            </a:r>
+            <a:r>
+              <a:rPr lang="en-US" dirty="0">
+                <a:solidFill>
+                  <a:srgbClr val="1F2937"/>
+                </a:solidFill>
+                <a:latin typeface="Calibri"/>
+              </a:rPr>
+              <a:t>– monitor over time</a:t>
+            </a:r>
+            <a:endParaRPr lang="en-US" b="1" dirty="0">
               <a:solidFill>
-                <a:srgbClr val="1F2937"/>
+                <a:srgbClr val="161F36"/>
               </a:solidFill>
               <a:latin typeface="Calibri"/>
             </a:endParaRPr>
@@ -14450,7 +14459,16 @@
                 </a:solidFill>
                 <a:latin typeface="Calibri"/>
               </a:rPr>
-              <a:t>Insights – general and per field</a:t>
+              <a:t>Insights </a:t>
+            </a:r>
+            <a:r>
+              <a:rPr lang="en-US" sz="1800" dirty="0">
+                <a:solidFill>
+                  <a:srgbClr val="161F36"/>
+                </a:solidFill>
+                <a:latin typeface="Calibri"/>
+              </a:rPr>
+              <a:t>– general and per field</a:t>
             </a:r>
             <a:endParaRPr sz="1800" dirty="0">
               <a:solidFill>

</xml_diff>